<commit_message>
Add AI text refinement feature using local Ollama model; update README and CLAUDE.md with new commands and model preferences
</commit_message>
<xml_diff>
--- a/Template/New Layout.pptx
+++ b/Template/New Layout.pptx
@@ -8,7 +8,7 @@
     <p:notesMasterId r:id="rId3"/>
   </p:notesMasterIdLst>
   <p:sldIdLst>
-    <p:sldId id="578" r:id="rId2"/>
+    <p:sldId id="579" r:id="rId2"/>
   </p:sldIdLst>
   <p:sldSz cx="12192000" cy="6858000"/>
   <p:notesSz cx="6858000" cy="9144000"/>
@@ -223,7 +223,7 @@
           <a:p>
             <a:fld id="{D2DC4F43-E7FC-4646-806C-CD3EDFAE8B86}" type="datetimeFigureOut">
               <a:rPr lang="zh-TW" altLang="en-US" smtClean="0"/>
-              <a:t>2026/4/21</a:t>
+              <a:t>2026/4/22</a:t>
             </a:fld>
             <a:endParaRPr lang="zh-TW" altLang="en-US"/>
           </a:p>
@@ -3297,8 +3297,8 @@
         </p:nvSpPr>
         <p:spPr>
           <a:xfrm>
-            <a:off x="129268" y="304802"/>
-            <a:ext cx="11933464" cy="627923"/>
+            <a:off x="129268" y="459098"/>
+            <a:ext cx="11933464" cy="461665"/>
           </a:xfrm>
           <a:ln w="9525">
             <a:solidFill>
@@ -3307,7 +3307,9 @@
           </a:ln>
         </p:spPr>
         <p:txBody>
-          <a:bodyPr/>
+          <a:bodyPr wrap="square">
+            <a:spAutoFit/>
+          </a:bodyPr>
           <a:lstStyle/>
           <a:p>
             <a:pPr algn="l"/>
@@ -3317,7 +3319,7 @@
                   <a:schemeClr val="tx1"/>
                 </a:solidFill>
               </a:rPr>
-              <a:t>PMO 8.19.1 - AI Advisor: Give advice button not hidden after canvas edit triggers Re-analyze</a:t>
+              <a:t>AI Advisor: Give advice button not hidden after canvas edit triggers Re-analyze</a:t>
             </a:r>
             <a:endParaRPr lang="zh-TW" altLang="en-US" sz="2000" dirty="0">
               <a:solidFill>
@@ -3345,7 +3347,9 @@
         </p:nvSpPr>
         <p:spPr/>
         <p:txBody>
-          <a:bodyPr/>
+          <a:bodyPr wrap="square">
+            <a:spAutoFit/>
+          </a:bodyPr>
           <a:lstStyle/>
           <a:p>
             <a:fld id="{48639955-E977-4B31-AA3E-D2FFF7C90C52}" type="slidenum">
@@ -3372,8 +3376,8 @@
         </p:nvSpPr>
         <p:spPr>
           <a:xfrm>
-            <a:off x="129268" y="1015361"/>
-            <a:ext cx="11933464" cy="369332"/>
+            <a:off x="129268" y="905191"/>
+            <a:ext cx="11933464" cy="386079"/>
           </a:xfrm>
           <a:prstGeom prst="rect">
             <a:avLst/>
@@ -3385,8 +3389,8 @@
           </a:ln>
         </p:spPr>
         <p:txBody>
-          <a:bodyPr vert="horz" lIns="91440" tIns="45720" rIns="91440" bIns="45720" rtlCol="0" anchor="ctr">
-            <a:normAutofit/>
+          <a:bodyPr vert="horz" wrap="square" lIns="91440" tIns="45720" rIns="91440" bIns="45720" rtlCol="0" anchor="ctr">
+            <a:spAutoFit/>
           </a:bodyPr>
           <a:lstStyle>
             <a:lvl1pPr algn="l" defTabSz="914400" rtl="0" eaLnBrk="1" latinLnBrk="0" hangingPunct="1">
@@ -3439,8 +3443,8 @@
         </p:nvSpPr>
         <p:spPr>
           <a:xfrm>
-            <a:off x="8761229" y="18448"/>
-            <a:ext cx="3301503" cy="369332"/>
+            <a:off x="8761229" y="15389"/>
+            <a:ext cx="3301503" cy="338554"/>
           </a:xfrm>
           <a:prstGeom prst="rect">
             <a:avLst/>
@@ -3455,12 +3459,12 @@
           <a:p>
             <a:pPr algn="ctr"/>
             <a:r>
-              <a:rPr lang="en-US" altLang="zh-TW" b="1" dirty="0">
+              <a:rPr lang="en-US" altLang="zh-TW" sz="1600" b="1" dirty="0">
                 <a:solidFill>
                   <a:srgbClr val="00B050"/>
                 </a:solidFill>
               </a:rPr>
-              <a:t>v8.20</a:t>
+              <a:t>PX, fix in X/X</a:t>
             </a:r>
           </a:p>
         </p:txBody>
@@ -3480,7 +3484,7 @@
         <p:spPr>
           <a:xfrm>
             <a:off x="12305841" y="2924668"/>
-            <a:ext cx="2324560" cy="276999"/>
+            <a:ext cx="2324560" cy="350519"/>
           </a:xfrm>
           <a:prstGeom prst="rect">
             <a:avLst/>
@@ -3527,17 +3531,12 @@
         </p:blipFill>
         <p:spPr>
           <a:xfrm>
-            <a:off x="1139980" y="1486381"/>
-            <a:ext cx="9912039" cy="5231922"/>
+            <a:off x="1139982" y="1376196"/>
+            <a:ext cx="9912004" cy="5231903"/>
           </a:xfrm>
           <a:prstGeom prst="rect">
             <a:avLst/>
           </a:prstGeom>
-          <a:ln>
-            <a:solidFill>
-              <a:schemeClr val="tx1"/>
-            </a:solidFill>
-          </a:ln>
         </p:spPr>
       </p:pic>
     </p:spTree>

</xml_diff>